<commit_message>
Slides: code labels in Be Vietnam Pro on sd-01-032 and sd-01-034, re-export badged PPTX
Co-Authored-By: Claude Opus 5.5 <noreply@anthropic.com>
Claude-Session: https://claude.ai/code/session_01PmqNRWe4NoiAuhPfHYj9Qq
</commit_message>
<xml_diff>
--- a/system-design-101/vi/lessons/sd-01-032/slides/sd-01-032.pptx
+++ b/system-design-101/vi/lessons/sd-01-032/slides/sd-01-032.pptx
@@ -34,10 +34,6 @@
     <p:embeddedFont>
       <p:font typeface="Be Vietnam Pro SemiBold"/>
       <p:regular r:id="rId20"/>
-    </p:embeddedFont>
-    <p:embeddedFont>
-      <p:font typeface="Roboto Mono"/>
-      <p:bold r:id="rId21"/>
     </p:embeddedFont>
   </p:embeddedFontLst>
   <p:defaultTextStyle>
@@ -9293,7 +9289,7 @@
           <a:ln/>
         </p:spPr>
         <p:txBody>
-          <a:bodyPr wrap="square" lIns="0" tIns="25374" rIns="0" bIns="-25374" rtlCol="0" anchor="t"/>
+          <a:bodyPr wrap="square" lIns="0" tIns="17002" rIns="0" bIns="-17002" rtlCol="0" anchor="t"/>
           <a:lstStyle/>
           <a:p>
             <a:pPr algn="l" indent="0" marL="0">
@@ -9303,46 +9299,68 @@
               <a:buNone/>
             </a:pPr>
             <a:r>
-              <a:rPr lang="en-US" sz="3150" b="1" dirty="0" spc="3" kern="0">
-                <a:solidFill>
-                  <a:srgbClr val="F3EEE3"/>
-                </a:solidFill>
-                <a:latin typeface="Roboto Mono" pitchFamily="34" charset="0"/>
-                <a:ea typeface="Roboto Mono" pitchFamily="34" charset="-122"/>
-                <a:cs typeface="Roboto Mono" pitchFamily="34" charset="-120"/>
-              </a:rPr>
-              <a:t>{ sach</a:t>
-            </a:r>
-            <a:r>
-              <a:rPr lang="en-US" sz="3150" b="1" dirty="0" spc="2" kern="0">
-                <a:solidFill>
-                  <a:srgbClr val="F3EEE3"/>
-                </a:solidFill>
-                <a:latin typeface="Roboto Mono" pitchFamily="34" charset="0"/>
-                <a:ea typeface="Roboto Mono" pitchFamily="34" charset="-122"/>
-                <a:cs typeface="Roboto Mono" pitchFamily="34" charset="-120"/>
+              <a:rPr lang="en-US" sz="3150" b="1" dirty="0" spc="0" kern="0">
+                <a:solidFill>
+                  <a:srgbClr val="F3EEE3"/>
+                </a:solidFill>
+                <a:latin typeface="Be Vietnam Pro" pitchFamily="34" charset="0"/>
+                <a:ea typeface="Be Vietnam Pro" pitchFamily="34" charset="-122"/>
+                <a:cs typeface="Be Vietnam Pro" pitchFamily="34" charset="-120"/>
+              </a:rPr>
+              <a:t>{</a:t>
+            </a:r>
+            <a:r>
+              <a:rPr lang="en-US" sz="3150" b="1" dirty="0" spc="1" kern="0">
+                <a:solidFill>
+                  <a:srgbClr val="F3EEE3"/>
+                </a:solidFill>
+                <a:latin typeface="Be Vietnam Pro" pitchFamily="34" charset="0"/>
+                <a:ea typeface="Be Vietnam Pro" pitchFamily="34" charset="-122"/>
+                <a:cs typeface="Be Vietnam Pro" pitchFamily="34" charset="-120"/>
+              </a:rPr>
+              <a:t> sach</a:t>
+            </a:r>
+            <a:r>
+              <a:rPr lang="en-US" sz="3150" b="1" dirty="0" spc="-1" kern="0">
+                <a:solidFill>
+                  <a:srgbClr val="F3EEE3"/>
+                </a:solidFill>
+                <a:latin typeface="Be Vietnam Pro" pitchFamily="34" charset="0"/>
+                <a:ea typeface="Be Vietnam Pro" pitchFamily="34" charset="-122"/>
+                <a:cs typeface="Be Vietnam Pro" pitchFamily="34" charset="-120"/>
               </a:rPr>
               <a:t> {</a:t>
             </a:r>
             <a:r>
-              <a:rPr lang="en-US" sz="3150" b="1" dirty="0" spc="3" kern="0">
-                <a:solidFill>
-                  <a:srgbClr val="F3EEE3"/>
-                </a:solidFill>
-                <a:latin typeface="Roboto Mono" pitchFamily="34" charset="0"/>
-                <a:ea typeface="Roboto Mono" pitchFamily="34" charset="-122"/>
-                <a:cs typeface="Roboto Mono" pitchFamily="34" charset="-120"/>
-              </a:rPr>
-              <a:t> ten }</a:t>
-            </a:r>
-            <a:r>
-              <a:rPr lang="en-US" sz="3150" b="1" dirty="0" spc="2" kern="0">
-                <a:solidFill>
-                  <a:srgbClr val="F3EEE3"/>
-                </a:solidFill>
-                <a:latin typeface="Roboto Mono" pitchFamily="34" charset="0"/>
-                <a:ea typeface="Roboto Mono" pitchFamily="34" charset="-122"/>
-                <a:cs typeface="Roboto Mono" pitchFamily="34" charset="-120"/>
+              <a:rPr lang="en-US" sz="3150" b="1" dirty="0" spc="-12" kern="0">
+                <a:solidFill>
+                  <a:srgbClr val="F3EEE3"/>
+                </a:solidFill>
+                <a:latin typeface="Be Vietnam Pro" pitchFamily="34" charset="0"/>
+                <a:ea typeface="Be Vietnam Pro" pitchFamily="34" charset="-122"/>
+                <a:cs typeface="Be Vietnam Pro" pitchFamily="34" charset="-120"/>
+              </a:rPr>
+              <a:t> ten</a:t>
+            </a:r>
+            <a:r>
+              <a:rPr lang="en-US" sz="3150" b="1" dirty="0" spc="0" kern="0">
+                <a:solidFill>
+                  <a:srgbClr val="F3EEE3"/>
+                </a:solidFill>
+                <a:latin typeface="Be Vietnam Pro" pitchFamily="34" charset="0"/>
+                <a:ea typeface="Be Vietnam Pro" pitchFamily="34" charset="-122"/>
+                <a:cs typeface="Be Vietnam Pro" pitchFamily="34" charset="-120"/>
+              </a:rPr>
+              <a:t> }</a:t>
+            </a:r>
+            <a:r>
+              <a:rPr lang="en-US" sz="3150" b="1" dirty="0" spc="-1" kern="0">
+                <a:solidFill>
+                  <a:srgbClr val="F3EEE3"/>
+                </a:solidFill>
+                <a:latin typeface="Be Vietnam Pro" pitchFamily="34" charset="0"/>
+                <a:ea typeface="Be Vietnam Pro" pitchFamily="34" charset="-122"/>
+                <a:cs typeface="Be Vietnam Pro" pitchFamily="34" charset="-120"/>
               </a:rPr>
               <a:t> }</a:t>
             </a:r>
@@ -10691,13 +10709,13 @@
               <a:buNone/>
             </a:pPr>
             <a:r>
-              <a:rPr lang="en-US" sz="3300" b="1" dirty="0" spc="5" kern="0">
+              <a:rPr lang="en-US" sz="3300" b="1" dirty="0" spc="-2" kern="0">
                 <a:solidFill>
                   <a:srgbClr val="E8472B"/>
                 </a:solidFill>
-                <a:latin typeface="Roboto Mono" pitchFamily="34" charset="0"/>
-                <a:ea typeface="Roboto Mono" pitchFamily="34" charset="-122"/>
-                <a:cs typeface="Roboto Mono" pitchFamily="34" charset="-120"/>
+                <a:latin typeface="Be Vietnam Pro" pitchFamily="34" charset="0"/>
+                <a:ea typeface="Be Vietnam Pro" pitchFamily="34" charset="-122"/>
+                <a:cs typeface="Be Vietnam Pro" pitchFamily="34" charset="-120"/>
               </a:rPr>
               <a:t>giuSach(42)</a:t>
             </a:r>

</xml_diff>